<commit_message>
docs(deck): add Tessera panel — five views, same landscape
Renders Tessera's prediction on the same tile as the other frames
(via render_endgame_frames --backbone-name tessera_v1) and adds it as a
fifth panel: NMD2018 label · v8b · NMD2023 label · Distilled Prithvi ·
Tessera. Tessera's map is as crisp as the 600M distilled model despite
being a frozen precomputed embedding — the visual counterpart to the
"ties the champion at a fraction of the compute" result.

Verified-by: validate.py PASSED; slide 8 rendered — five panels fit cleanly, legend intact, no overflow
Co-Authored-By: Claude Opus 4.8 <noreply@anthropic.com>
</commit_message>
<xml_diff>
--- a/docs/decks/v8b_nfi_conference.pptx
+++ b/docs/decks/v8b_nfi_conference.pptx
@@ -3102,7 +3102,7 @@
           <a:p>
             <a:r>
               <a:rPr lang="en-US" dirty="0"/>
-              <a:t>Qualitatively, the same 5-by-5 kilometre tile through four lenses. Left to right: the 2018 NMD label, our model trained on 2018, the 2023 NMD label, and the distilled NFI model. The distilled output is visibly crisper and more coherent than the label it learned from — denoising you can see, not just measure.</a:t>
+              <a:t>Qualitatively, the same 5-by-5 kilometre tile through five lenses. Left to right: the 2018 NMD label, our model trained on 2018, the 2023 NMD label, the distilled Prithvi model, and Tessera. Both models' outputs are visibly crisper and more coherent than the labels they learned from — denoising you can see, not just measure — and Tessera matches the 600-million-parameter Prithvi from a frozen, precomputed embedding.</a:t>
             </a:r>
             <a:endParaRPr lang="en-US" dirty="0"/>
           </a:p>
@@ -12330,7 +12330,7 @@
                 <a:ea typeface="Space Grotesk" pitchFamily="34" charset="-122"/>
                 <a:cs typeface="Space Grotesk" pitchFamily="34" charset="-120"/>
               </a:rPr>
-              <a:t>Four generations, same landscape</a:t>
+              <a:t>Five views, same landscape</a:t>
             </a:r>
             <a:endParaRPr lang="en-US" sz="3200" dirty="0"/>
           </a:p>
@@ -12369,7 +12369,7 @@
                 <a:ea typeface="Space Grotesk" pitchFamily="34" charset="-122"/>
                 <a:cs typeface="Space Grotesk" pitchFamily="34" charset="-120"/>
               </a:rPr>
-              <a:t>One 5×5 km tile, identical extent and unified palette (tile_331280_6541280): the 2018/2023 label sources and the models trained against each target.</a:t>
+              <a:t>One 5×5 km tile, identical extent and unified palette (tile_331280_6541280): the 2018/2023 label sources, and three models — v8b, the distilled Prithvi, and Tessera — each trained against the field-calibrated target.</a:t>
             </a:r>
             <a:endParaRPr lang="en-US" sz="1250" dirty="0"/>
           </a:p>
@@ -12391,8 +12391,8 @@
         </p:blipFill>
         <p:spPr>
           <a:xfrm>
-            <a:off x="585216" y="1737360"/>
-            <a:ext cx="2651760" cy="2651760"/>
+            <a:off x="598932" y="1783080"/>
+            <a:ext cx="2103120" cy="2103120"/>
           </a:xfrm>
           <a:prstGeom prst="rect">
             <a:avLst/>
@@ -12407,8 +12407,8 @@
         </p:nvSpPr>
         <p:spPr>
           <a:xfrm>
-            <a:off x="539496" y="4434840"/>
-            <a:ext cx="2743200" cy="320040"/>
+            <a:off x="553212" y="3931920"/>
+            <a:ext cx="2194560" cy="320040"/>
           </a:xfrm>
           <a:prstGeom prst="rect">
             <a:avLst/>
@@ -12454,8 +12454,8 @@
         </p:blipFill>
         <p:spPr>
           <a:xfrm>
-            <a:off x="3374136" y="1737360"/>
-            <a:ext cx="2651760" cy="2651760"/>
+            <a:off x="2820924" y="1783080"/>
+            <a:ext cx="2103120" cy="2103120"/>
           </a:xfrm>
           <a:prstGeom prst="rect">
             <a:avLst/>
@@ -12470,8 +12470,8 @@
         </p:nvSpPr>
         <p:spPr>
           <a:xfrm>
-            <a:off x="3328416" y="4434840"/>
-            <a:ext cx="2743200" cy="320040"/>
+            <a:off x="2775204" y="3931920"/>
+            <a:ext cx="2194560" cy="320040"/>
           </a:xfrm>
           <a:prstGeom prst="rect">
             <a:avLst/>
@@ -12517,8 +12517,8 @@
         </p:blipFill>
         <p:spPr>
           <a:xfrm>
-            <a:off x="6163056" y="1737360"/>
-            <a:ext cx="2651760" cy="2651760"/>
+            <a:off x="5042916" y="1783080"/>
+            <a:ext cx="2103120" cy="2103120"/>
           </a:xfrm>
           <a:prstGeom prst="rect">
             <a:avLst/>
@@ -12533,8 +12533,8 @@
         </p:nvSpPr>
         <p:spPr>
           <a:xfrm>
-            <a:off x="6117336" y="4434840"/>
-            <a:ext cx="2743200" cy="320040"/>
+            <a:off x="4997196" y="3931920"/>
+            <a:ext cx="2194560" cy="320040"/>
           </a:xfrm>
           <a:prstGeom prst="rect">
             <a:avLst/>
@@ -12580,8 +12580,8 @@
         </p:blipFill>
         <p:spPr>
           <a:xfrm>
-            <a:off x="8951976" y="1737360"/>
-            <a:ext cx="2651760" cy="2651760"/>
+            <a:off x="7264908" y="1783080"/>
+            <a:ext cx="2103120" cy="2103120"/>
           </a:xfrm>
           <a:prstGeom prst="rect">
             <a:avLst/>
@@ -12596,8 +12596,8 @@
         </p:nvSpPr>
         <p:spPr>
           <a:xfrm>
-            <a:off x="8906256" y="4434840"/>
-            <a:ext cx="2743200" cy="320040"/>
+            <a:off x="7219188" y="3931920"/>
+            <a:ext cx="2194560" cy="320040"/>
           </a:xfrm>
           <a:prstGeom prst="rect">
             <a:avLst/>
@@ -12621,15 +12621,78 @@
                 <a:ea typeface="Space Grotesk" pitchFamily="34" charset="-122"/>
                 <a:cs typeface="Space Grotesk" pitchFamily="34" charset="-120"/>
               </a:rPr>
-              <a:t>v8b-NFI (distilled)</a:t>
+              <a:t>Distilled Prithvi</a:t>
             </a:r>
             <a:endParaRPr lang="en-US" sz="1250" dirty="0"/>
           </a:p>
         </p:txBody>
       </p:sp>
-      <p:sp>
-        <p:nvSpPr>
-          <p:cNvPr id="13" name="Shape 7"/>
+      <p:pic>
+        <p:nvPicPr>
+          <p:cNvPr id="13" name="Image 4" descr="preencoded.png">    </p:cNvPr>
+          <p:cNvPicPr>
+            <a:picLocks noChangeAspect="1"/>
+          </p:cNvPicPr>
+          <p:nvPr/>
+        </p:nvPicPr>
+        <p:blipFill>
+          <a:blip r:embed="rId5"/>
+          <a:stretch>
+            <a:fillRect/>
+          </a:stretch>
+        </p:blipFill>
+        <p:spPr>
+          <a:xfrm>
+            <a:off x="9486900" y="1783080"/>
+            <a:ext cx="2103120" cy="2103120"/>
+          </a:xfrm>
+          <a:prstGeom prst="rect">
+            <a:avLst/>
+          </a:prstGeom>
+        </p:spPr>
+      </p:pic>
+      <p:sp>
+        <p:nvSpPr>
+          <p:cNvPr id="14" name="Text 7"/>
+          <p:cNvSpPr/>
+          <p:nvPr/>
+        </p:nvSpPr>
+        <p:spPr>
+          <a:xfrm>
+            <a:off x="9441180" y="3931920"/>
+            <a:ext cx="2194560" cy="320040"/>
+          </a:xfrm>
+          <a:prstGeom prst="rect">
+            <a:avLst/>
+          </a:prstGeom>
+          <a:noFill/>
+          <a:ln/>
+        </p:spPr>
+        <p:txBody>
+          <a:bodyPr wrap="square" lIns="0" tIns="0" rIns="0" bIns="0" rtlCol="0" anchor="ctr"/>
+          <a:lstStyle/>
+          <a:p>
+            <a:pPr algn="ctr" indent="0" marL="0">
+              <a:buNone/>
+            </a:pPr>
+            <a:r>
+              <a:rPr lang="en-US" sz="1250" b="1" dirty="0">
+                <a:solidFill>
+                  <a:srgbClr val="F2C879"/>
+                </a:solidFill>
+                <a:latin typeface="Space Grotesk" pitchFamily="34" charset="0"/>
+                <a:ea typeface="Space Grotesk" pitchFamily="34" charset="-122"/>
+                <a:cs typeface="Space Grotesk" pitchFamily="34" charset="-120"/>
+              </a:rPr>
+              <a:t>Tessera</a:t>
+            </a:r>
+            <a:endParaRPr lang="en-US" sz="1250" dirty="0"/>
+          </a:p>
+        </p:txBody>
+      </p:sp>
+      <p:sp>
+        <p:nvSpPr>
+          <p:cNvPr id="15" name="Shape 8"/>
           <p:cNvSpPr/>
           <p:nvPr/>
         </p:nvSpPr>
@@ -12649,7 +12712,7 @@
       </p:sp>
       <p:sp>
         <p:nvSpPr>
-          <p:cNvPr id="14" name="Text 8"/>
+          <p:cNvPr id="16" name="Text 9"/>
           <p:cNvSpPr/>
           <p:nvPr/>
         </p:nvSpPr>
@@ -12688,7 +12751,7 @@
       </p:sp>
       <p:sp>
         <p:nvSpPr>
-          <p:cNvPr id="15" name="Shape 9"/>
+          <p:cNvPr id="17" name="Shape 10"/>
           <p:cNvSpPr/>
           <p:nvPr/>
         </p:nvSpPr>
@@ -12708,7 +12771,7 @@
       </p:sp>
       <p:sp>
         <p:nvSpPr>
-          <p:cNvPr id="16" name="Text 10"/>
+          <p:cNvPr id="18" name="Text 11"/>
           <p:cNvSpPr/>
           <p:nvPr/>
         </p:nvSpPr>
@@ -12747,7 +12810,7 @@
       </p:sp>
       <p:sp>
         <p:nvSpPr>
-          <p:cNvPr id="17" name="Shape 11"/>
+          <p:cNvPr id="19" name="Shape 12"/>
           <p:cNvSpPr/>
           <p:nvPr/>
         </p:nvSpPr>
@@ -12767,7 +12830,7 @@
       </p:sp>
       <p:sp>
         <p:nvSpPr>
-          <p:cNvPr id="18" name="Text 12"/>
+          <p:cNvPr id="20" name="Text 13"/>
           <p:cNvSpPr/>
           <p:nvPr/>
         </p:nvSpPr>
@@ -12806,7 +12869,7 @@
       </p:sp>
       <p:sp>
         <p:nvSpPr>
-          <p:cNvPr id="19" name="Shape 13"/>
+          <p:cNvPr id="21" name="Shape 14"/>
           <p:cNvSpPr/>
           <p:nvPr/>
         </p:nvSpPr>
@@ -12826,7 +12889,7 @@
       </p:sp>
       <p:sp>
         <p:nvSpPr>
-          <p:cNvPr id="20" name="Text 14"/>
+          <p:cNvPr id="22" name="Text 15"/>
           <p:cNvSpPr/>
           <p:nvPr/>
         </p:nvSpPr>
@@ -12865,7 +12928,7 @@
       </p:sp>
       <p:sp>
         <p:nvSpPr>
-          <p:cNvPr id="21" name="Shape 15"/>
+          <p:cNvPr id="23" name="Shape 16"/>
           <p:cNvSpPr/>
           <p:nvPr/>
         </p:nvSpPr>
@@ -12885,7 +12948,7 @@
       </p:sp>
       <p:sp>
         <p:nvSpPr>
-          <p:cNvPr id="22" name="Text 16"/>
+          <p:cNvPr id="24" name="Text 17"/>
           <p:cNvSpPr/>
           <p:nvPr/>
         </p:nvSpPr>
@@ -12924,7 +12987,7 @@
       </p:sp>
       <p:sp>
         <p:nvSpPr>
-          <p:cNvPr id="23" name="Shape 17"/>
+          <p:cNvPr id="25" name="Shape 18"/>
           <p:cNvSpPr/>
           <p:nvPr/>
         </p:nvSpPr>
@@ -12944,7 +13007,7 @@
       </p:sp>
       <p:sp>
         <p:nvSpPr>
-          <p:cNvPr id="24" name="Text 18"/>
+          <p:cNvPr id="26" name="Text 19"/>
           <p:cNvSpPr/>
           <p:nvPr/>
         </p:nvSpPr>
@@ -12983,7 +13046,7 @@
       </p:sp>
       <p:sp>
         <p:nvSpPr>
-          <p:cNvPr id="25" name="Shape 19"/>
+          <p:cNvPr id="27" name="Shape 20"/>
           <p:cNvSpPr/>
           <p:nvPr/>
         </p:nvSpPr>
@@ -13003,7 +13066,7 @@
       </p:sp>
       <p:sp>
         <p:nvSpPr>
-          <p:cNvPr id="26" name="Text 20"/>
+          <p:cNvPr id="28" name="Text 21"/>
           <p:cNvSpPr/>
           <p:nvPr/>
         </p:nvSpPr>
@@ -13042,7 +13105,7 @@
       </p:sp>
       <p:sp>
         <p:nvSpPr>
-          <p:cNvPr id="27" name="Shape 21"/>
+          <p:cNvPr id="29" name="Shape 22"/>
           <p:cNvSpPr/>
           <p:nvPr/>
         </p:nvSpPr>
@@ -13062,7 +13125,7 @@
       </p:sp>
       <p:sp>
         <p:nvSpPr>
-          <p:cNvPr id="28" name="Text 22"/>
+          <p:cNvPr id="30" name="Text 23"/>
           <p:cNvSpPr/>
           <p:nvPr/>
         </p:nvSpPr>
@@ -13101,7 +13164,7 @@
       </p:sp>
       <p:sp>
         <p:nvSpPr>
-          <p:cNvPr id="29" name="Shape 23"/>
+          <p:cNvPr id="31" name="Shape 24"/>
           <p:cNvSpPr/>
           <p:nvPr/>
         </p:nvSpPr>
@@ -13121,7 +13184,7 @@
       </p:sp>
       <p:sp>
         <p:nvSpPr>
-          <p:cNvPr id="30" name="Text 24"/>
+          <p:cNvPr id="32" name="Text 25"/>
           <p:cNvSpPr/>
           <p:nvPr/>
         </p:nvSpPr>
@@ -13160,7 +13223,7 @@
       </p:sp>
       <p:sp>
         <p:nvSpPr>
-          <p:cNvPr id="31" name="Shape 25"/>
+          <p:cNvPr id="33" name="Shape 26"/>
           <p:cNvSpPr/>
           <p:nvPr/>
         </p:nvSpPr>
@@ -13180,7 +13243,7 @@
       </p:sp>
       <p:sp>
         <p:nvSpPr>
-          <p:cNvPr id="32" name="Text 26"/>
+          <p:cNvPr id="34" name="Text 27"/>
           <p:cNvSpPr/>
           <p:nvPr/>
         </p:nvSpPr>
@@ -13219,7 +13282,7 @@
       </p:sp>
       <p:sp>
         <p:nvSpPr>
-          <p:cNvPr id="33" name="Shape 27"/>
+          <p:cNvPr id="35" name="Shape 28"/>
           <p:cNvSpPr/>
           <p:nvPr/>
         </p:nvSpPr>
@@ -13239,7 +13302,7 @@
       </p:sp>
       <p:sp>
         <p:nvSpPr>
-          <p:cNvPr id="34" name="Text 28"/>
+          <p:cNvPr id="36" name="Text 29"/>
           <p:cNvSpPr/>
           <p:nvPr/>
         </p:nvSpPr>
@@ -13278,7 +13341,7 @@
       </p:sp>
       <p:sp>
         <p:nvSpPr>
-          <p:cNvPr id="35" name="Shape 29"/>
+          <p:cNvPr id="37" name="Shape 30"/>
           <p:cNvSpPr/>
           <p:nvPr/>
         </p:nvSpPr>
@@ -13298,7 +13361,7 @@
       </p:sp>
       <p:sp>
         <p:nvSpPr>
-          <p:cNvPr id="36" name="Text 30"/>
+          <p:cNvPr id="38" name="Text 31"/>
           <p:cNvSpPr/>
           <p:nvPr/>
         </p:nvSpPr>

</xml_diff>